<commit_message>
Align learning site with HireFromPH navy and gold branding
</commit_message>
<xml_diff>
--- a/public/kit/decks/master-presenter.pptx
+++ b/public/kit/decks/master-presenter.pptx
@@ -2561,7 +2561,7 @@
       </p:grpSpPr>
       <p:pic>
         <p:nvPicPr>
-          <p:cNvPr id="2" name="Image 0" descr="C:\Users\llino\AppData\Local\Temp\hfph-decks-hOWO7d\master-title.jpg">    </p:cNvPr>
+          <p:cNvPr id="2" name="Image 0" descr="C:\Users\DEVELO~1\AppData\Local\Temp\hfph-decks-OLkhm9\master-title.jpg">    </p:cNvPr>
           <p:cNvPicPr>
             <a:picLocks noChangeAspect="1"/>
           </p:cNvPicPr>
@@ -2610,7 +2610,7 @@
       </p:grpSpPr>
       <p:pic>
         <p:nvPicPr>
-          <p:cNvPr id="2" name="Image 0" descr="C:\Users\llino\AppData\Local\Temp\hfph-decks-hOWO7d\master-method-deconstruct.jpg">    </p:cNvPr>
+          <p:cNvPr id="2" name="Image 0" descr="C:\Users\DEVELO~1\AppData\Local\Temp\hfph-decks-OLkhm9\master-method-deconstruct.jpg">    </p:cNvPr>
           <p:cNvPicPr>
             <a:picLocks noChangeAspect="1"/>
           </p:cNvPicPr>
@@ -2659,7 +2659,7 @@
       </p:grpSpPr>
       <p:pic>
         <p:nvPicPr>
-          <p:cNvPr id="2" name="Image 0" descr="C:\Users\llino\AppData\Local\Temp\hfph-decks-hOWO7d\master-method-learn.jpg">    </p:cNvPr>
+          <p:cNvPr id="2" name="Image 0" descr="C:\Users\DEVELO~1\AppData\Local\Temp\hfph-decks-OLkhm9\master-method-learn.jpg">    </p:cNvPr>
           <p:cNvPicPr>
             <a:picLocks noChangeAspect="1"/>
           </p:cNvPicPr>
@@ -2708,7 +2708,7 @@
       </p:grpSpPr>
       <p:pic>
         <p:nvPicPr>
-          <p:cNvPr id="2" name="Image 0" descr="C:\Users\llino\AppData\Local\Temp\hfph-decks-hOWO7d\master-method-vet.jpg">    </p:cNvPr>
+          <p:cNvPr id="2" name="Image 0" descr="C:\Users\DEVELO~1\AppData\Local\Temp\hfph-decks-OLkhm9\master-method-vet.jpg">    </p:cNvPr>
           <p:cNvPicPr>
             <a:picLocks noChangeAspect="1"/>
           </p:cNvPicPr>
@@ -2757,7 +2757,7 @@
       </p:grpSpPr>
       <p:pic>
         <p:nvPicPr>
-          <p:cNvPr id="2" name="Image 0" descr="C:\Users\llino\AppData\Local\Temp\hfph-decks-hOWO7d\master-method-ask.jpg">    </p:cNvPr>
+          <p:cNvPr id="2" name="Image 0" descr="C:\Users\DEVELO~1\AppData\Local\Temp\hfph-decks-OLkhm9\master-method-ask.jpg">    </p:cNvPr>
           <p:cNvPicPr>
             <a:picLocks noChangeAspect="1"/>
           </p:cNvPicPr>
@@ -2806,7 +2806,7 @@
       </p:grpSpPr>
       <p:pic>
         <p:nvPicPr>
-          <p:cNvPr id="2" name="Image 0" descr="C:\Users\llino\AppData\Local\Temp\hfph-decks-hOWO7d\master-method-unstick.jpg">    </p:cNvPr>
+          <p:cNvPr id="2" name="Image 0" descr="C:\Users\DEVELO~1\AppData\Local\Temp\hfph-decks-OLkhm9\master-method-unstick.jpg">    </p:cNvPr>
           <p:cNvPicPr>
             <a:picLocks noChangeAspect="1"/>
           </p:cNvPicPr>
@@ -2855,7 +2855,7 @@
       </p:grpSpPr>
       <p:pic>
         <p:nvPicPr>
-          <p:cNvPr id="2" name="Image 0" descr="C:\Users\llino\AppData\Local\Temp\hfph-decks-hOWO7d\master-method-give.jpg">    </p:cNvPr>
+          <p:cNvPr id="2" name="Image 0" descr="C:\Users\DEVELO~1\AppData\Local\Temp\hfph-decks-OLkhm9\master-method-give.jpg">    </p:cNvPr>
           <p:cNvPicPr>
             <a:picLocks noChangeAspect="1"/>
           </p:cNvPicPr>
@@ -2904,7 +2904,7 @@
       </p:grpSpPr>
       <p:pic>
         <p:nvPicPr>
-          <p:cNvPr id="2" name="Image 0" descr="C:\Users\llino\AppData\Local\Temp\hfph-decks-hOWO7d\master-method-loop.jpg">    </p:cNvPr>
+          <p:cNvPr id="2" name="Image 0" descr="C:\Users\DEVELO~1\AppData\Local\Temp\hfph-decks-OLkhm9\master-method-loop.jpg">    </p:cNvPr>
           <p:cNvPicPr>
             <a:picLocks noChangeAspect="1"/>
           </p:cNvPicPr>
@@ -2953,7 +2953,7 @@
       </p:grpSpPr>
       <p:pic>
         <p:nvPicPr>
-          <p:cNvPr id="2" name="Image 0" descr="C:\Users\llino\AppData\Local\Temp\hfph-decks-hOWO7d\master-anti-patterns.jpg">    </p:cNvPr>
+          <p:cNvPr id="2" name="Image 0" descr="C:\Users\DEVELO~1\AppData\Local\Temp\hfph-decks-OLkhm9\master-anti-patterns.jpg">    </p:cNvPr>
           <p:cNvPicPr>
             <a:picLocks noChangeAspect="1"/>
           </p:cNvPicPr>
@@ -3002,7 +3002,7 @@
       </p:grpSpPr>
       <p:pic>
         <p:nvPicPr>
-          <p:cNvPr id="2" name="Image 0" descr="C:\Users\llino\AppData\Local\Temp\hfph-decks-hOWO7d\master-run-a-session.jpg">    </p:cNvPr>
+          <p:cNvPr id="2" name="Image 0" descr="C:\Users\DEVELO~1\AppData\Local\Temp\hfph-decks-OLkhm9\master-run-a-session.jpg">    </p:cNvPr>
           <p:cNvPicPr>
             <a:picLocks noChangeAspect="1"/>
           </p:cNvPicPr>
@@ -3051,7 +3051,7 @@
       </p:grpSpPr>
       <p:pic>
         <p:nvPicPr>
-          <p:cNvPr id="2" name="Image 0" descr="C:\Users\llino\AppData\Local\Temp\hfph-decks-hOWO7d\master-chapter-close.jpg">    </p:cNvPr>
+          <p:cNvPr id="2" name="Image 0" descr="C:\Users\DEVELO~1\AppData\Local\Temp\hfph-decks-OLkhm9\master-chapter-close.jpg">    </p:cNvPr>
           <p:cNvPicPr>
             <a:picLocks noChangeAspect="1"/>
           </p:cNvPicPr>
@@ -3100,7 +3100,7 @@
       </p:grpSpPr>
       <p:pic>
         <p:nvPicPr>
-          <p:cNvPr id="2" name="Image 0" descr="C:\Users\llino\AppData\Local\Temp\hfph-decks-hOWO7d\master-chapter-why.jpg">    </p:cNvPr>
+          <p:cNvPr id="2" name="Image 0" descr="C:\Users\DEVELO~1\AppData\Local\Temp\hfph-decks-OLkhm9\master-chapter-why.jpg">    </p:cNvPr>
           <p:cNvPicPr>
             <a:picLocks noChangeAspect="1"/>
           </p:cNvPicPr>
@@ -3149,7 +3149,7 @@
       </p:grpSpPr>
       <p:pic>
         <p:nvPicPr>
-          <p:cNvPr id="2" name="Image 0" descr="C:\Users\llino\AppData\Local\Temp\hfph-decks-hOWO7d\master-licence.jpg">    </p:cNvPr>
+          <p:cNvPr id="2" name="Image 0" descr="C:\Users\DEVELO~1\AppData\Local\Temp\hfph-decks-OLkhm9\master-licence.jpg">    </p:cNvPr>
           <p:cNvPicPr>
             <a:picLocks noChangeAspect="1"/>
           </p:cNvPicPr>
@@ -3198,7 +3198,7 @@
       </p:grpSpPr>
       <p:pic>
         <p:nvPicPr>
-          <p:cNvPr id="2" name="Image 0" descr="C:\Users\llino\AppData\Local\Temp\hfph-decks-hOWO7d\master-honesty.jpg">    </p:cNvPr>
+          <p:cNvPr id="2" name="Image 0" descr="C:\Users\DEVELO~1\AppData\Local\Temp\hfph-decks-OLkhm9\master-honesty.jpg">    </p:cNvPr>
           <p:cNvPicPr>
             <a:picLocks noChangeAspect="1"/>
           </p:cNvPicPr>
@@ -3247,7 +3247,7 @@
       </p:grpSpPr>
       <p:pic>
         <p:nvPicPr>
-          <p:cNvPr id="2" name="Image 0" descr="C:\Users\llino\AppData\Local\Temp\hfph-decks-hOWO7d\master-method-over-material.jpg">    </p:cNvPr>
+          <p:cNvPr id="2" name="Image 0" descr="C:\Users\DEVELO~1\AppData\Local\Temp\hfph-decks-OLkhm9\master-method-over-material.jpg">    </p:cNvPr>
           <p:cNvPicPr>
             <a:picLocks noChangeAspect="1"/>
           </p:cNvPicPr>
@@ -3296,7 +3296,7 @@
       </p:grpSpPr>
       <p:pic>
         <p:nvPicPr>
-          <p:cNvPr id="2" name="Image 0" descr="C:\Users\llino\AppData\Local\Temp\hfph-decks-hOWO7d\master-chapter-path.jpg">    </p:cNvPr>
+          <p:cNvPr id="2" name="Image 0" descr="C:\Users\DEVELO~1\AppData\Local\Temp\hfph-decks-OLkhm9\master-chapter-path.jpg">    </p:cNvPr>
           <p:cNvPicPr>
             <a:picLocks noChangeAspect="1"/>
           </p:cNvPicPr>
@@ -3345,7 +3345,7 @@
       </p:grpSpPr>
       <p:pic>
         <p:nvPicPr>
-          <p:cNvPr id="2" name="Image 0" descr="C:\Users\llino\AppData\Local\Temp\hfph-decks-hOWO7d\master-five-stages.jpg">    </p:cNvPr>
+          <p:cNvPr id="2" name="Image 0" descr="C:\Users\DEVELO~1\AppData\Local\Temp\hfph-decks-OLkhm9\master-five-stages.jpg">    </p:cNvPr>
           <p:cNvPicPr>
             <a:picLocks noChangeAspect="1"/>
           </p:cNvPicPr>
@@ -3394,7 +3394,7 @@
       </p:grpSpPr>
       <p:pic>
         <p:nvPicPr>
-          <p:cNvPr id="2" name="Image 0" descr="C:\Users\llino\AppData\Local\Temp\hfph-decks-hOWO7d\master-eleven-steps.jpg">    </p:cNvPr>
+          <p:cNvPr id="2" name="Image 0" descr="C:\Users\DEVELO~1\AppData\Local\Temp\hfph-decks-OLkhm9\master-eleven-steps.jpg">    </p:cNvPr>
           <p:cNvPicPr>
             <a:picLocks noChangeAspect="1"/>
           </p:cNvPicPr>
@@ -3443,7 +3443,7 @@
       </p:grpSpPr>
       <p:pic>
         <p:nvPicPr>
-          <p:cNvPr id="2" name="Image 0" descr="C:\Users\llino\AppData\Local\Temp\hfph-decks-hOWO7d\master-chapter-methods.jpg">    </p:cNvPr>
+          <p:cNvPr id="2" name="Image 0" descr="C:\Users\DEVELO~1\AppData\Local\Temp\hfph-decks-OLkhm9\master-chapter-methods.jpg">    </p:cNvPr>
           <p:cNvPicPr>
             <a:picLocks noChangeAspect="1"/>
           </p:cNvPicPr>
@@ -3492,7 +3492,7 @@
       </p:grpSpPr>
       <p:pic>
         <p:nvPicPr>
-          <p:cNvPr id="2" name="Image 0" descr="C:\Users\llino\AppData\Local\Temp\hfph-decks-hOWO7d\master-method-find.jpg">    </p:cNvPr>
+          <p:cNvPr id="2" name="Image 0" descr="C:\Users\DEVELO~1\AppData\Local\Temp\hfph-decks-OLkhm9\master-method-find.jpg">    </p:cNvPr>
           <p:cNvPicPr>
             <a:picLocks noChangeAspect="1"/>
           </p:cNvPicPr>

</xml_diff>